<commit_message>
Exclude warranty/campaign PNs from commercial H1 Parts Performance movers.
Claim-grain PN cut (plus text heuristic) is now the locked sales-review basis for every DB; IBX deck rebuilt so slide 3 reviews aftermarket demand, not blended warranty.

Co-authored-by: Cursor <cursoragent@cursor.com>
</commit_message>
<xml_diff>
--- a/09_meetings/IBX_Sales_Review_2026/ISZE_IBX_Sales_Review_FY2027.pptx
+++ b/09_meetings/IBX_Sales_Review_2026/ISZE_IBX_Sales_Review_FY2027.pptx
@@ -5686,6 +5686,34 @@
                 </a:solidFill>
                 <a:latin typeface="Calibri"/>
               </a:rPr>
+              <a:t>End-2026 mix: LCV / D-Max 9,154; CV — LD 136.</a:t>
+            </a:r>
+          </a:p>
+          <a:p>
+            <a:pPr>
+              <a:lnSpc>
+                <a:spcPct val="125000"/>
+              </a:lnSpc>
+              <a:spcAft>
+                <a:spcPts val="1000"/>
+              </a:spcAft>
+            </a:pPr>
+            <a:r>
+              <a:rPr sz="1250" b="1">
+                <a:solidFill>
+                  <a:srgbClr val="CC0E1E"/>
+                </a:solidFill>
+                <a:latin typeface="Calibri"/>
+              </a:rPr>
+              <a:t>—  </a:t>
+            </a:r>
+            <a:r>
+              <a:rPr sz="1250">
+                <a:solidFill>
+                  <a:srgbClr val="1A1A1A"/>
+                </a:solidFill>
+                <a:latin typeface="Calibri"/>
+              </a:rPr>
               <a:t>The FY2027 Sales-to-Dealer target starts from that fleet change, then applies a 5% price adjustment and 1.8% additional growth.</a:t>
             </a:r>
           </a:p>
@@ -10232,7 +10260,7 @@
                 </a:solidFill>
                 <a:latin typeface="Calibri"/>
               </a:rPr>
-              <a:t>Steering / Brake parts / Fuel system: agree which category we tackle first, and what the joint action is.</a:t>
+              <a:t>Brake parts / Injectors / Fuel system: agree which category we tackle first, and what the joint action is.</a:t>
             </a:r>
           </a:p>
           <a:p>
@@ -10636,7 +10664,7 @@
                 </a:solidFill>
                 <a:latin typeface="Calibri"/>
               </a:rPr>
-              <a:t>Parts Performance — Steering</a:t>
+              <a:t>Parts Performance — Brake parts</a:t>
             </a:r>
           </a:p>
           <a:p>
@@ -10664,7 +10692,7 @@
                 </a:solidFill>
                 <a:latin typeface="Calibri"/>
               </a:rPr>
-              <a:t>Parts Performance — Brake parts</a:t>
+              <a:t>Parts Performance — Injectors</a:t>
             </a:r>
           </a:p>
           <a:p>
@@ -11796,7 +11824,7 @@
                 </a:solidFill>
                 <a:latin typeface="Calibri"/>
               </a:rPr>
-              <a:t>GPS — calendar year and fiscal year on one chart (incl. warranty)</a:t>
+              <a:t>GPS — fiscal year (headline vs excl. warranty; max two lines)</a:t>
             </a:r>
           </a:p>
           <a:p>
@@ -11852,7 +11880,7 @@
                 </a:solidFill>
                 <a:latin typeface="Calibri"/>
               </a:rPr>
-              <a:t>Where the money went — outside the service-parts basket</a:t>
+              <a:t>Where the money went — outside the service-parts basket (FY)</a:t>
             </a:r>
           </a:p>
           <a:p>
@@ -11880,7 +11908,7 @@
                 </a:solidFill>
                 <a:latin typeface="Calibri"/>
               </a:rPr>
-              <a:t>Service parts: calendar-year capture vs network + fiscal-year billing</a:t>
+              <a:t>Service parts: CY capture vs network + FY billing (capture % is CY-only by design)</a:t>
             </a:r>
           </a:p>
           <a:p>
@@ -11908,7 +11936,7 @@
                 </a:solidFill>
                 <a:latin typeface="Calibri"/>
               </a:rPr>
-              <a:t>Brake pads — BVP share of total brake pad sales</a:t>
+              <a:t>Brake pads — BVP share of total brake pad sales (FY)</a:t>
             </a:r>
           </a:p>
           <a:p>
@@ -12155,7 +12183,7 @@
                 </a:solidFill>
                 <a:latin typeface="Calibri"/>
               </a:rPr>
-              <a:t>GPS: calendar year, fiscal year, and after warranty</a:t>
+              <a:t>GPS: fiscal year headline vs after warranty</a:t>
             </a:r>
           </a:p>
         </p:txBody>
@@ -12386,7 +12414,7 @@
                 </a:solidFill>
                 <a:latin typeface="Calibri"/>
               </a:rPr>
-              <a:t>Red = calendar-year GPS. Recent peak 86.9%; CY2025 = 86.0%.</a:t>
+              <a:t>Red = fiscal-year GPS (frozen CY2025 wallet). FY25 90.9% → FY26 85.2%.</a:t>
             </a:r>
           </a:p>
           <a:p>
@@ -12414,7 +12442,7 @@
                 </a:solidFill>
                 <a:latin typeface="Calibri"/>
               </a:rPr>
-              <a:t>Black = fiscal-year GPS (frozen CY2025 wallet). FY26 headline 85.2%.</a:t>
+              <a:t>Black = fiscal GPS after removing warranty parts (€). FY26 ≈ 81.8% (warranty EUR 83,007 ≈ 4% of FY26 billing).</a:t>
             </a:r>
           </a:p>
           <a:p>
@@ -12442,35 +12470,7 @@
                 </a:solidFill>
                 <a:latin typeface="Calibri"/>
               </a:rPr>
-              <a:t>Grey = fiscal GPS after removing warranty parts (€). FY26 ≈ 81.8% (warranty EUR 83,007 ≈ 4% of FY26 billing).</a:t>
-            </a:r>
-          </a:p>
-          <a:p>
-            <a:pPr>
-              <a:lnSpc>
-                <a:spcPct val="125000"/>
-              </a:lnSpc>
-              <a:spcAft>
-                <a:spcPts val="1000"/>
-              </a:spcAft>
-            </a:pPr>
-            <a:r>
-              <a:rPr sz="1250" b="1">
-                <a:solidFill>
-                  <a:srgbClr val="CC0E1E"/>
-                </a:solidFill>
-                <a:latin typeface="Calibri"/>
-              </a:rPr>
-              <a:t>—  </a:t>
-            </a:r>
-            <a:r>
-              <a:rPr sz="1250">
-                <a:solidFill>
-                  <a:srgbClr val="1A1A1A"/>
-                </a:solidFill>
-                <a:latin typeface="Calibri"/>
-              </a:rPr>
-              <a:t>Fleet 9,593 → 9,290 (working CY2026 estimate).</a:t>
+              <a:t>Fleet 9,593 → 9,290 (working year-end estimate under the FY2027 target).</a:t>
             </a:r>
           </a:p>
           <a:p>
@@ -13894,7 +13894,7 @@
                 </a:solidFill>
                 <a:latin typeface="Calibri"/>
               </a:rPr>
-              <a:t>Where the genuine drop sits (calendar 2024 → 2025)</a:t>
+              <a:t>Where the genuine drop sits (FY2025 → FY2026)</a:t>
             </a:r>
           </a:p>
         </p:txBody>
@@ -14023,7 +14023,7 @@
                 </a:solidFill>
                 <a:latin typeface="Calibri"/>
               </a:rPr>
-              <a:t>Genuine-only sales moved EUR 78,321 from CY2024 to CY2025.</a:t>
+              <a:t>Genuine-only sales moved EUR -94,412 from FY2025 to FY2026.</a:t>
             </a:r>
           </a:p>
           <a:p>
@@ -14051,7 +14051,35 @@
                 </a:solidFill>
                 <a:latin typeface="Calibri"/>
               </a:rPr>
-              <a:t>Of that, the routine service basket (filters, pads, rotors) moved EUR -7,355 on genuine-only; BVP in that basket moved EUR -1,467.</a:t>
+              <a:t>Of that, the routine service basket (filters, pads, rotors) moved EUR -9,608 on genuine-only; BVP in that basket moved EUR 2,350.</a:t>
+            </a:r>
+          </a:p>
+          <a:p>
+            <a:pPr>
+              <a:lnSpc>
+                <a:spcPct val="125000"/>
+              </a:lnSpc>
+              <a:spcAft>
+                <a:spcPts val="1000"/>
+              </a:spcAft>
+            </a:pPr>
+            <a:r>
+              <a:rPr sz="1500" b="1">
+                <a:solidFill>
+                  <a:srgbClr val="CC0E1E"/>
+                </a:solidFill>
+                <a:latin typeface="Calibri"/>
+              </a:rPr>
+              <a:t>—  </a:t>
+            </a:r>
+            <a:r>
+              <a:rPr sz="1500">
+                <a:solidFill>
+                  <a:srgbClr val="1A1A1A"/>
+                </a:solidFill>
+                <a:latin typeface="Calibri"/>
+              </a:rPr>
+              <a:t>So about 90% of the genuine-only drop sits outside routine service parts.</a:t>
             </a:r>
           </a:p>
           <a:p>
@@ -16057,7 +16085,7 @@
                 </a:solidFill>
                 <a:latin typeface="Calibri"/>
               </a:rPr>
-              <a:t>Parts Performance — CY H1 2026 vs CY H1 2025</a:t>
+              <a:t>Parts Performance — CY H1 2026 vs CY H1 2025 (commercial, ex-warranty)</a:t>
             </a:r>
           </a:p>
         </p:txBody>
@@ -16288,7 +16316,7 @@
                 </a:solidFill>
                 <a:latin typeface="Calibri"/>
               </a:rPr>
-              <a:t>Parts billing EUR 1,235K against EUR 1,057K a year earlier — +16.8%. After EUR 25K of credit notes the net figure is EUR 1,209K.</a:t>
+              <a:t>Commercial parts billing (warranty/campaign excluded) EUR 1,029K against EUR 828K a year earlier — +24.3%.</a:t>
             </a:r>
           </a:p>
           <a:p>
@@ -16316,7 +16344,7 @@
                 </a:solidFill>
                 <a:latin typeface="Calibri"/>
               </a:rPr>
-              <a:t>Biggest declines: Steering EUR -54K; Brake parts EUR -9K; Fuel system EUR -4K.</a:t>
+              <a:t>Credit notes of EUR 25K remain a separate commercial adjustment on the net bridge (net EUR 1,209K); they are not in the movers.</a:t>
             </a:r>
           </a:p>
           <a:p>
@@ -16344,7 +16372,7 @@
                 </a:solidFill>
                 <a:latin typeface="Calibri"/>
               </a:rPr>
-              <a:t>Growing: Body parts +36%, Exhaust +85%, Electrical sensors +38%.</a:t>
+              <a:t>Biggest commercial declines: Brake parts EUR -13K; Injectors EUR -5K; Fuel system EUR -4K.</a:t>
             </a:r>
           </a:p>
           <a:p>
@@ -16372,7 +16400,7 @@
                 </a:solidFill>
                 <a:latin typeface="Calibri"/>
               </a:rPr>
-              <a:t>CY H1 2026 against CY H1 2025 (calendar Jan–Jun, Q1+Q2) — like-for-like half-year cut.</a:t>
+              <a:t>Growing: Body parts +36%, Exhaust +70%, Lighting +29%.</a:t>
             </a:r>
           </a:p>
         </p:txBody>
@@ -16535,7 +16563,7 @@
                 </a:solidFill>
                 <a:latin typeface="Calibri"/>
               </a:rPr>
-              <a:t>Brake pads — BVP share of total brake pad sales</a:t>
+              <a:t>Brake pads — BVP share of total brake pad sales (FY)</a:t>
             </a:r>
           </a:p>
         </p:txBody>
@@ -16678,7 +16706,7 @@
                           </a:solidFill>
                           <a:latin typeface="Calibri"/>
                         </a:rPr>
-                        <a:t>2024</a:t>
+                        <a:t>FY2025</a:t>
                       </a:r>
                     </a:p>
                   </a:txBody>
@@ -16701,7 +16729,7 @@
                           </a:solidFill>
                           <a:latin typeface="Calibri"/>
                         </a:rPr>
-                        <a:t>2025</a:t>
+                        <a:t>FY2026</a:t>
                       </a:r>
                     </a:p>
                   </a:txBody>
@@ -16891,7 +16919,7 @@
                           </a:solidFill>
                           <a:latin typeface="Calibri"/>
                         </a:rPr>
-                        <a:t>14%</a:t>
+                        <a:t>12%</a:t>
                       </a:r>
                     </a:p>
                   </a:txBody>
@@ -16914,7 +16942,7 @@
                           </a:solidFill>
                           <a:latin typeface="Calibri"/>
                         </a:rPr>
-                        <a:t>3%</a:t>
+                        <a:t>6%</a:t>
                       </a:r>
                     </a:p>
                   </a:txBody>
@@ -19216,7 +19244,7 @@
                 </a:solidFill>
                 <a:latin typeface="Calibri"/>
               </a:rPr>
-              <a:t>PARTS PERFORMANCE — STEERING</a:t>
+              <a:t>PARTS PERFORMANCE — BRAKE PARTS</a:t>
             </a:r>
           </a:p>
         </p:txBody>
@@ -19251,7 +19279,7 @@
                 </a:solidFill>
                 <a:latin typeface="Calibri"/>
               </a:rPr>
-              <a:t>Steering — CY H1 2026 vs CY H1 2025</a:t>
+              <a:t>Brake parts — CY H1 2026 vs CY H1 2025 (commercial, ex-warranty)</a:t>
             </a:r>
           </a:p>
         </p:txBody>
@@ -19380,7 +19408,7 @@
                 </a:solidFill>
                 <a:latin typeface="Calibri"/>
               </a:rPr>
-              <a:t>EUR 96,368 (CY H1 2025) to EUR 42,053 (CY H1 2026), down EUR 54,315 (-56%).</a:t>
+              <a:t>EUR 42,206 (CY H1 2025) to EUR 29,058 (CY H1 2026), down EUR 13,148 (-31%).</a:t>
             </a:r>
           </a:p>
           <a:p>
@@ -19408,67 +19436,9 @@
                 </a:solidFill>
                 <a:latin typeface="Calibri"/>
               </a:rPr>
-              <a:t>7552348290 (STEERING UNIT): EUR 75,208 to EUR 16,010, 29 fewer pieces.</a:t>
-            </a:r>
-          </a:p>
-        </p:txBody>
-      </p:sp>
-      <p:sp>
-        <p:nvSpPr>
-          <p:cNvPr id="9" name="TextBox 8"/>
-          <p:cNvSpPr txBox="1"/>
-          <p:nvPr/>
-        </p:nvSpPr>
-        <p:spPr>
-          <a:xfrm>
-            <a:off x="292608" y="3840480"/>
-            <a:ext cx="8595360" cy="274320"/>
-          </a:xfrm>
-          <a:prstGeom prst="rect">
-            <a:avLst/>
-          </a:prstGeom>
-          <a:noFill/>
-        </p:spPr>
-        <p:txBody>
-          <a:bodyPr wrap="square">
-            <a:spAutoFit/>
-          </a:bodyPr>
-          <a:lstStyle/>
-          <a:p>
-            <a:pPr algn="l"/>
-            <a:r>
-              <a:rPr sz="1300" b="1">
-                <a:solidFill>
-                  <a:srgbClr val="CC0E1E"/>
-                </a:solidFill>
-                <a:latin typeface="Calibri"/>
-              </a:rPr>
-              <a:t>Questions for us to work through together</a:t>
-            </a:r>
-          </a:p>
-        </p:txBody>
-      </p:sp>
-      <p:sp>
-        <p:nvSpPr>
-          <p:cNvPr id="10" name="TextBox 9"/>
-          <p:cNvSpPr txBox="1"/>
-          <p:nvPr/>
-        </p:nvSpPr>
-        <p:spPr>
-          <a:xfrm>
-            <a:off x="292608" y="4160520"/>
-            <a:ext cx="11612880" cy="1737360"/>
-          </a:xfrm>
-          <a:prstGeom prst="rect">
-            <a:avLst/>
-          </a:prstGeom>
-          <a:noFill/>
-        </p:spPr>
-        <p:txBody>
-          <a:bodyPr wrap="square">
-            <a:spAutoFit/>
-          </a:bodyPr>
-          <a:lstStyle/>
+              <a:t>5878316930 (SHOE KIT; BRAKE,RR): EUR 12,755 to EUR 0, 62 fewer pieces.</a:t>
+            </a:r>
+          </a:p>
           <a:p>
             <a:pPr>
               <a:lnSpc>
@@ -19494,9 +19464,67 @@
                 </a:solidFill>
                 <a:latin typeface="Calibri"/>
               </a:rPr>
-              <a:t>Is this pricing against what the dealers can buy locally?</a:t>
-            </a:r>
-          </a:p>
+              <a:t>5876102280 (LINING KIT; RR BRAKE): EUR 3,276 to EUR 0, 57 fewer pieces.</a:t>
+            </a:r>
+          </a:p>
+        </p:txBody>
+      </p:sp>
+      <p:sp>
+        <p:nvSpPr>
+          <p:cNvPr id="9" name="TextBox 8"/>
+          <p:cNvSpPr txBox="1"/>
+          <p:nvPr/>
+        </p:nvSpPr>
+        <p:spPr>
+          <a:xfrm>
+            <a:off x="292608" y="3840480"/>
+            <a:ext cx="8595360" cy="274320"/>
+          </a:xfrm>
+          <a:prstGeom prst="rect">
+            <a:avLst/>
+          </a:prstGeom>
+          <a:noFill/>
+        </p:spPr>
+        <p:txBody>
+          <a:bodyPr wrap="square">
+            <a:spAutoFit/>
+          </a:bodyPr>
+          <a:lstStyle/>
+          <a:p>
+            <a:pPr algn="l"/>
+            <a:r>
+              <a:rPr sz="1300" b="1">
+                <a:solidFill>
+                  <a:srgbClr val="CC0E1E"/>
+                </a:solidFill>
+                <a:latin typeface="Calibri"/>
+              </a:rPr>
+              <a:t>Questions for us to work through together</a:t>
+            </a:r>
+          </a:p>
+        </p:txBody>
+      </p:sp>
+      <p:sp>
+        <p:nvSpPr>
+          <p:cNvPr id="10" name="TextBox 9"/>
+          <p:cNvSpPr txBox="1"/>
+          <p:nvPr/>
+        </p:nvSpPr>
+        <p:spPr>
+          <a:xfrm>
+            <a:off x="292608" y="4160520"/>
+            <a:ext cx="11612880" cy="1737360"/>
+          </a:xfrm>
+          <a:prstGeom prst="rect">
+            <a:avLst/>
+          </a:prstGeom>
+          <a:noFill/>
+        </p:spPr>
+        <p:txBody>
+          <a:bodyPr wrap="square">
+            <a:spAutoFit/>
+          </a:bodyPr>
+          <a:lstStyle/>
           <a:p>
             <a:pPr>
               <a:lnSpc>
@@ -19522,7 +19550,7 @@
                 </a:solidFill>
                 <a:latin typeface="Calibri"/>
               </a:rPr>
-              <a:t>Is any of this stock timing on your side rather than end demand?</a:t>
+              <a:t>Is pad and rotor pricing competitive against what the dealers can buy locally?</a:t>
             </a:r>
           </a:p>
           <a:p>
@@ -19550,7 +19578,35 @@
                 </a:solidFill>
                 <a:latin typeface="Calibri"/>
               </a:rPr>
-              <a:t>What would make the biggest difference to keep this business with us?</a:t>
+              <a:t>Is any of this stock timing on your side rather than end demand?</a:t>
+            </a:r>
+          </a:p>
+          <a:p>
+            <a:pPr>
+              <a:lnSpc>
+                <a:spcPct val="125000"/>
+              </a:lnSpc>
+              <a:spcAft>
+                <a:spcPts val="1000"/>
+              </a:spcAft>
+            </a:pPr>
+            <a:r>
+              <a:rPr sz="1400" b="1">
+                <a:solidFill>
+                  <a:srgbClr val="CC0E1E"/>
+                </a:solidFill>
+                <a:latin typeface="Calibri"/>
+              </a:rPr>
+              <a:t>—  </a:t>
+            </a:r>
+            <a:r>
+              <a:rPr sz="1400">
+                <a:solidFill>
+                  <a:srgbClr val="1A1A1A"/>
+                </a:solidFill>
+                <a:latin typeface="Calibri"/>
+              </a:rPr>
+              <a:t>Are dealers still quoting these part numbers, or have they dropped off the workshop menu?</a:t>
             </a:r>
           </a:p>
         </p:txBody>
@@ -19678,7 +19734,7 @@
                 </a:solidFill>
                 <a:latin typeface="Calibri"/>
               </a:rPr>
-              <a:t>PARTS PERFORMANCE — BRAKE PARTS</a:t>
+              <a:t>PARTS PERFORMANCE — INJECTORS</a:t>
             </a:r>
           </a:p>
         </p:txBody>
@@ -19713,7 +19769,7 @@
                 </a:solidFill>
                 <a:latin typeface="Calibri"/>
               </a:rPr>
-              <a:t>Brake parts — CY H1 2026 vs CY H1 2025</a:t>
+              <a:t>Injectors — CY H1 2026 vs CY H1 2025 (commercial, ex-warranty)</a:t>
             </a:r>
           </a:p>
         </p:txBody>
@@ -19842,9 +19898,67 @@
                 </a:solidFill>
                 <a:latin typeface="Calibri"/>
               </a:rPr>
-              <a:t>EUR 90,882 (CY H1 2025) to EUR 81,978 (CY H1 2026), down EUR 8,904 (-10%).</a:t>
-            </a:r>
-          </a:p>
+              <a:t>EUR 10,591 (CY H1 2025) to EUR 5,795 (CY H1 2026), down EUR 4,796 (-45%).</a:t>
+            </a:r>
+          </a:p>
+        </p:txBody>
+      </p:sp>
+      <p:sp>
+        <p:nvSpPr>
+          <p:cNvPr id="9" name="TextBox 8"/>
+          <p:cNvSpPr txBox="1"/>
+          <p:nvPr/>
+        </p:nvSpPr>
+        <p:spPr>
+          <a:xfrm>
+            <a:off x="292608" y="3840480"/>
+            <a:ext cx="8595360" cy="274320"/>
+          </a:xfrm>
+          <a:prstGeom prst="rect">
+            <a:avLst/>
+          </a:prstGeom>
+          <a:noFill/>
+        </p:spPr>
+        <p:txBody>
+          <a:bodyPr wrap="square">
+            <a:spAutoFit/>
+          </a:bodyPr>
+          <a:lstStyle/>
+          <a:p>
+            <a:pPr algn="l"/>
+            <a:r>
+              <a:rPr sz="1300" b="1">
+                <a:solidFill>
+                  <a:srgbClr val="CC0E1E"/>
+                </a:solidFill>
+                <a:latin typeface="Calibri"/>
+              </a:rPr>
+              <a:t>Questions for us to work through together</a:t>
+            </a:r>
+          </a:p>
+        </p:txBody>
+      </p:sp>
+      <p:sp>
+        <p:nvSpPr>
+          <p:cNvPr id="10" name="TextBox 9"/>
+          <p:cNvSpPr txBox="1"/>
+          <p:nvPr/>
+        </p:nvSpPr>
+        <p:spPr>
+          <a:xfrm>
+            <a:off x="292608" y="4160520"/>
+            <a:ext cx="11612880" cy="1737360"/>
+          </a:xfrm>
+          <a:prstGeom prst="rect">
+            <a:avLst/>
+          </a:prstGeom>
+          <a:noFill/>
+        </p:spPr>
+        <p:txBody>
+          <a:bodyPr wrap="square">
+            <a:spAutoFit/>
+          </a:bodyPr>
+          <a:lstStyle/>
           <a:p>
             <a:pPr>
               <a:lnSpc>
@@ -19870,7 +19984,7 @@
                 </a:solidFill>
                 <a:latin typeface="Calibri"/>
               </a:rPr>
-              <a:t>5878316930 (SHOE KIT; BRAKE,RR): EUR 12,755 to EUR 0, 62 fewer pieces.</a:t>
+              <a:t>Is this fewer failures, or repairs moving out of the network?</a:t>
             </a:r>
           </a:p>
           <a:p>
@@ -19898,149 +20012,7 @@
                 </a:solidFill>
                 <a:latin typeface="Calibri"/>
               </a:rPr>
-              <a:t>8975546610 (PAD KIT; CALIPER,DISC BRK,FRT): EUR 9,648 to EUR 5,842, 44 fewer pieces.</a:t>
-            </a:r>
-          </a:p>
-          <a:p>
-            <a:pPr>
-              <a:lnSpc>
-                <a:spcPct val="125000"/>
-              </a:lnSpc>
-              <a:spcAft>
-                <a:spcPts val="1000"/>
-              </a:spcAft>
-            </a:pPr>
-            <a:r>
-              <a:rPr sz="1400" b="1">
-                <a:solidFill>
-                  <a:srgbClr val="CC0E1E"/>
-                </a:solidFill>
-                <a:latin typeface="Calibri"/>
-              </a:rPr>
-              <a:t>—  </a:t>
-            </a:r>
-            <a:r>
-              <a:rPr sz="1400">
-                <a:solidFill>
-                  <a:srgbClr val="1A1A1A"/>
-                </a:solidFill>
-                <a:latin typeface="Calibri"/>
-              </a:rPr>
-              <a:t>5876102280 (LINING KIT; RR BRAKE): EUR 3,276 to EUR 0, 57 fewer pieces.</a:t>
-            </a:r>
-          </a:p>
-        </p:txBody>
-      </p:sp>
-      <p:sp>
-        <p:nvSpPr>
-          <p:cNvPr id="9" name="TextBox 8"/>
-          <p:cNvSpPr txBox="1"/>
-          <p:nvPr/>
-        </p:nvSpPr>
-        <p:spPr>
-          <a:xfrm>
-            <a:off x="292608" y="3840480"/>
-            <a:ext cx="8595360" cy="274320"/>
-          </a:xfrm>
-          <a:prstGeom prst="rect">
-            <a:avLst/>
-          </a:prstGeom>
-          <a:noFill/>
-        </p:spPr>
-        <p:txBody>
-          <a:bodyPr wrap="square">
-            <a:spAutoFit/>
-          </a:bodyPr>
-          <a:lstStyle/>
-          <a:p>
-            <a:pPr algn="l"/>
-            <a:r>
-              <a:rPr sz="1300" b="1">
-                <a:solidFill>
-                  <a:srgbClr val="CC0E1E"/>
-                </a:solidFill>
-                <a:latin typeface="Calibri"/>
-              </a:rPr>
-              <a:t>Questions for us to work through together</a:t>
-            </a:r>
-          </a:p>
-        </p:txBody>
-      </p:sp>
-      <p:sp>
-        <p:nvSpPr>
-          <p:cNvPr id="10" name="TextBox 9"/>
-          <p:cNvSpPr txBox="1"/>
-          <p:nvPr/>
-        </p:nvSpPr>
-        <p:spPr>
-          <a:xfrm>
-            <a:off x="292608" y="4160520"/>
-            <a:ext cx="11612880" cy="1737360"/>
-          </a:xfrm>
-          <a:prstGeom prst="rect">
-            <a:avLst/>
-          </a:prstGeom>
-          <a:noFill/>
-        </p:spPr>
-        <p:txBody>
-          <a:bodyPr wrap="square">
-            <a:spAutoFit/>
-          </a:bodyPr>
-          <a:lstStyle/>
-          <a:p>
-            <a:pPr>
-              <a:lnSpc>
-                <a:spcPct val="125000"/>
-              </a:lnSpc>
-              <a:spcAft>
-                <a:spcPts val="1000"/>
-              </a:spcAft>
-            </a:pPr>
-            <a:r>
-              <a:rPr sz="1400" b="1">
-                <a:solidFill>
-                  <a:srgbClr val="CC0E1E"/>
-                </a:solidFill>
-                <a:latin typeface="Calibri"/>
-              </a:rPr>
-              <a:t>—  </a:t>
-            </a:r>
-            <a:r>
-              <a:rPr sz="1400">
-                <a:solidFill>
-                  <a:srgbClr val="1A1A1A"/>
-                </a:solidFill>
-                <a:latin typeface="Calibri"/>
-              </a:rPr>
-              <a:t>Is pad and rotor pricing competitive against what the dealers can buy locally?</a:t>
-            </a:r>
-          </a:p>
-          <a:p>
-            <a:pPr>
-              <a:lnSpc>
-                <a:spcPct val="125000"/>
-              </a:lnSpc>
-              <a:spcAft>
-                <a:spcPts val="1000"/>
-              </a:spcAft>
-            </a:pPr>
-            <a:r>
-              <a:rPr sz="1400" b="1">
-                <a:solidFill>
-                  <a:srgbClr val="CC0E1E"/>
-                </a:solidFill>
-                <a:latin typeface="Calibri"/>
-              </a:rPr>
-              <a:t>—  </a:t>
-            </a:r>
-            <a:r>
-              <a:rPr sz="1400">
-                <a:solidFill>
-                  <a:srgbClr val="1A1A1A"/>
-                </a:solidFill>
-                <a:latin typeface="Calibri"/>
-              </a:rPr>
-              <a:t>Is any of this stock timing on your side rather than end demand?</a:t>
+              <a:t>Is the exchange/reman route competing with new parts here?</a:t>
             </a:r>
           </a:p>
           <a:p>
@@ -20231,7 +20203,7 @@
                 </a:solidFill>
                 <a:latin typeface="Calibri"/>
               </a:rPr>
-              <a:t>Fuel system — CY H1 2026 vs CY H1 2025</a:t>
+              <a:t>Fuel system — CY H1 2026 vs CY H1 2025 (commercial, ex-warranty)</a:t>
             </a:r>
           </a:p>
         </p:txBody>
@@ -20360,7 +20332,7 @@
                 </a:solidFill>
                 <a:latin typeface="Calibri"/>
               </a:rPr>
-              <a:t>EUR 9,894 (CY H1 2025) to EUR 5,766 (CY H1 2026), down EUR 4,128 (-42%).</a:t>
+              <a:t>EUR 9,894 (CY H1 2025) to EUR 5,548 (CY H1 2026), down EUR 4,346 (-44%).</a:t>
             </a:r>
           </a:p>
         </p:txBody>
@@ -20665,7 +20637,7 @@
                 </a:solidFill>
                 <a:latin typeface="Calibri"/>
               </a:rPr>
-              <a:t>Where volume grew — CY H1 2026 vs CY H1 2025</a:t>
+              <a:t>Where volume grew — CY H1 2026 vs CY H1 2025 (commercial, ex-warranty)</a:t>
             </a:r>
           </a:p>
         </p:txBody>
@@ -21256,7 +21228,7 @@
                           </a:solidFill>
                           <a:latin typeface="Calibri"/>
                         </a:rPr>
-                        <a:t>8983682091</a:t>
+                        <a:t>8983320764</a:t>
                       </a:r>
                     </a:p>
                   </a:txBody>
@@ -21279,7 +21251,7 @@
                           </a:solidFill>
                           <a:latin typeface="Calibri"/>
                         </a:rPr>
-                        <a:t>PIPE; EXH</a:t>
+                        <a:t>DPD ASM</a:t>
                       </a:r>
                     </a:p>
                   </a:txBody>
@@ -21302,7 +21274,7 @@
                           </a:solidFill>
                           <a:latin typeface="Calibri"/>
                         </a:rPr>
-                        <a:t>EUR 2,725</a:t>
+                        <a:t>EUR 2,283</a:t>
                       </a:r>
                     </a:p>
                   </a:txBody>
@@ -21325,7 +21297,7 @@
                           </a:solidFill>
                           <a:latin typeface="Calibri"/>
                         </a:rPr>
-                        <a:t>EUR 7,917</a:t>
+                        <a:t>EUR 6,849</a:t>
                       </a:r>
                     </a:p>
                   </a:txBody>
@@ -21350,7 +21322,7 @@
                           </a:solidFill>
                           <a:latin typeface="Calibri"/>
                         </a:rPr>
-                        <a:t>8983320764</a:t>
+                        <a:t>8975359391</a:t>
                       </a:r>
                     </a:p>
                   </a:txBody>
@@ -21396,7 +21368,7 @@
                           </a:solidFill>
                           <a:latin typeface="Calibri"/>
                         </a:rPr>
-                        <a:t>EUR 2,283</a:t>
+                        <a:t>EUR 4,694</a:t>
                       </a:r>
                     </a:p>
                   </a:txBody>
@@ -21419,7 +21391,7 @@
                           </a:solidFill>
                           <a:latin typeface="Calibri"/>
                         </a:rPr>
-                        <a:t>EUR 6,849</a:t>
+                        <a:t>EUR 9,218</a:t>
                       </a:r>
                     </a:p>
                   </a:txBody>
@@ -21480,7 +21452,7 @@
                 </a:solidFill>
                 <a:latin typeface="Calibri"/>
               </a:rPr>
-              <a:t>Body parts +36%, Exhaust +85%, Electrical sensors +38% — where the volume went.</a:t>
+              <a:t>Body parts +36%, Exhaust +70%, Lighting +29% — where the commercial volume went.</a:t>
             </a:r>
           </a:p>
           <a:p>
@@ -21508,7 +21480,7 @@
                 </a:solidFill>
                 <a:latin typeface="Calibri"/>
               </a:rPr>
-              <a:t>Several of these are the kind of item that also moves on a campaign or claim. Belgium CY2025 warranty parts (claim-price basis) were EUR 75K — separate from fiscal GPS warranty expense. Do not read this growth list as purely commercial without checking claims together.</a:t>
+              <a:t>Claim-matched PNs (187 distinct) and campaign/recall text matches are already excluded from this growth list. Residual warranty on unmapped PNs can remain.</a:t>
             </a:r>
           </a:p>
           <a:p>

</xml_diff>

<commit_message>
Clarify movers takeaways: all-category PN gains vs within top rising category.
IBX Body parts +EUR 102K is a sum of many PNs; the global top-3 gainers mix categories and cannot explain the Body bar alone. Label PN deltas as all-categories and add a Within-{cat} callout; ship the Body PN increase CSV with the rebuilt IBX deck.

Co-authored-by: Cursor <cursoragent@cursor.com>
</commit_message>
<xml_diff>
--- a/09_meetings/IBX_Sales_Review_2026/ISZE_IBX_Sales_Review_FY2027.pptx
+++ b/09_meetings/IBX_Sales_Review_2026/ISZE_IBX_Sales_Review_FY2027.pptx
@@ -16316,7 +16316,7 @@
                 </a:solidFill>
                 <a:latin typeface="Calibri"/>
               </a:rPr>
-              <a:t>Commercial parts billing (warranty/campaign excluded) EUR 1,029K against EUR 828K a year earlier — +24.3%.</a:t>
+              <a:t>Commercial parts billing (warranty/campaign excluded) EUR 1,029K against EUR 828K a year earlier — +24.3% (CY H1 2026 vs CY H1 2025, Jan–Jun).</a:t>
             </a:r>
           </a:p>
           <a:p>
@@ -16344,7 +16344,7 @@
                 </a:solidFill>
                 <a:latin typeface="Calibri"/>
               </a:rPr>
-              <a:t>Credit notes of EUR 25K remain a separate commercial adjustment on the net bridge (net EUR 1,209K); they are not in the movers.</a:t>
+              <a:t>Largest PN drops (all categories): 5878316930 (SHOE KIT; BRAKE,RR) EUR -13K, 62 fewer pcs; 8974725274 (RAIL; ROOF) EUR -4K, 34 fewer pcs; 8977988670 (TRANSFER ASM) EUR -4K, 2 fewer pcs.</a:t>
             </a:r>
           </a:p>
           <a:p>
@@ -16372,7 +16372,7 @@
                 </a:solidFill>
                 <a:latin typeface="Calibri"/>
               </a:rPr>
-              <a:t>Biggest commercial declines: Brake parts EUR -13K; Injectors EUR -5K; Fuel system EUR -4K.</a:t>
+              <a:t>Largest PN gains (all categories): 8978461152 (GLASS; WINDSHIELD) EUR 18K, 79 more pcs; 8981776324 (DPD ASM) EUR 8K, 6 more pcs; 8975554500 (FILTER; BLOWER UNIT) [TF*,UC*] EUR 7K, 407 more pcs.</a:t>
             </a:r>
           </a:p>
           <a:p>
@@ -16400,7 +16400,7 @@
                 </a:solidFill>
                 <a:latin typeface="Calibri"/>
               </a:rPr>
-              <a:t>Growing: Body parts +36%, Exhaust +70%, Lighting +29%.</a:t>
+              <a:t>Within Body parts (EUR 102K, +36%): 8978461152 (GLASS; WINDSHIELD) EUR 18K, 79 more pcs; 8975595830 (PANEL; SIDE GATE) EUR 4K, 19 more pcs; 7552172691 (BUMPER ASM; FRT) EUR 4K, 26 more pcs.</a:t>
             </a:r>
           </a:p>
         </p:txBody>
@@ -19393,7 +19393,7 @@
               </a:spcAft>
             </a:pPr>
             <a:r>
-              <a:rPr sz="1400" b="1">
+              <a:rPr sz="1300" b="1">
                 <a:solidFill>
                   <a:srgbClr val="CC0E1E"/>
                 </a:solidFill>
@@ -19402,7 +19402,7 @@
               <a:t>—  </a:t>
             </a:r>
             <a:r>
-              <a:rPr sz="1400">
+              <a:rPr sz="1300">
                 <a:solidFill>
                   <a:srgbClr val="1A1A1A"/>
                 </a:solidFill>
@@ -19421,7 +19421,7 @@
               </a:spcAft>
             </a:pPr>
             <a:r>
-              <a:rPr sz="1400" b="1">
+              <a:rPr sz="1300" b="1">
                 <a:solidFill>
                   <a:srgbClr val="CC0E1E"/>
                 </a:solidFill>
@@ -19430,13 +19430,13 @@
               <a:t>—  </a:t>
             </a:r>
             <a:r>
-              <a:rPr sz="1400">
+              <a:rPr sz="1300">
                 <a:solidFill>
                   <a:srgbClr val="1A1A1A"/>
                 </a:solidFill>
                 <a:latin typeface="Calibri"/>
               </a:rPr>
-              <a:t>5878316930 (SHOE KIT; BRAKE,RR): EUR 12,755 to EUR 0, 62 fewer pieces.</a:t>
+              <a:t>Largest part numbers driving the decline (by EUR):</a:t>
             </a:r>
           </a:p>
           <a:p>
@@ -19449,7 +19449,7 @@
               </a:spcAft>
             </a:pPr>
             <a:r>
-              <a:rPr sz="1400" b="1">
+              <a:rPr sz="1300" b="1">
                 <a:solidFill>
                   <a:srgbClr val="CC0E1E"/>
                 </a:solidFill>
@@ -19458,13 +19458,97 @@
               <a:t>—  </a:t>
             </a:r>
             <a:r>
-              <a:rPr sz="1400">
+              <a:rPr sz="1300">
                 <a:solidFill>
                   <a:srgbClr val="1A1A1A"/>
                 </a:solidFill>
                 <a:latin typeface="Calibri"/>
               </a:rPr>
-              <a:t>5876102280 (LINING KIT; RR BRAKE): EUR 3,276 to EUR 0, 57 fewer pieces.</a:t>
+              <a:t>5878316930 (SHOE KIT; BRAKE,RR): EUR 12,755 to EUR 0, 62 fewer pieces.</a:t>
+            </a:r>
+          </a:p>
+          <a:p>
+            <a:pPr>
+              <a:lnSpc>
+                <a:spcPct val="125000"/>
+              </a:lnSpc>
+              <a:spcAft>
+                <a:spcPts val="1000"/>
+              </a:spcAft>
+            </a:pPr>
+            <a:r>
+              <a:rPr sz="1300" b="1">
+                <a:solidFill>
+                  <a:srgbClr val="CC0E1E"/>
+                </a:solidFill>
+                <a:latin typeface="Calibri"/>
+              </a:rPr>
+              <a:t>—  </a:t>
+            </a:r>
+            <a:r>
+              <a:rPr sz="1300">
+                <a:solidFill>
+                  <a:srgbClr val="1A1A1A"/>
+                </a:solidFill>
+                <a:latin typeface="Calibri"/>
+              </a:rPr>
+              <a:t>5876102280 (LINING KIT; RR BRAKE · NPR,NQR,NNR): EUR 3,276 to EUR 0, 57 fewer pieces.</a:t>
+            </a:r>
+          </a:p>
+          <a:p>
+            <a:pPr>
+              <a:lnSpc>
+                <a:spcPct val="125000"/>
+              </a:lnSpc>
+              <a:spcAft>
+                <a:spcPts val="1000"/>
+              </a:spcAft>
+            </a:pPr>
+            <a:r>
+              <a:rPr sz="1300" b="1">
+                <a:solidFill>
+                  <a:srgbClr val="CC0E1E"/>
+                </a:solidFill>
+                <a:latin typeface="Calibri"/>
+              </a:rPr>
+              <a:t>—  </a:t>
+            </a:r>
+            <a:r>
+              <a:rPr sz="1300">
+                <a:solidFill>
+                  <a:srgbClr val="1A1A1A"/>
+                </a:solidFill>
+                <a:latin typeface="Calibri"/>
+              </a:rPr>
+              <a:t>8981246634 (ROTOR; DISC BRK,FRT): EUR 1,335 to EUR 375, 11 fewer pieces.</a:t>
+            </a:r>
+          </a:p>
+          <a:p>
+            <a:pPr>
+              <a:lnSpc>
+                <a:spcPct val="125000"/>
+              </a:lnSpc>
+              <a:spcAft>
+                <a:spcPts val="1000"/>
+              </a:spcAft>
+            </a:pPr>
+            <a:r>
+              <a:rPr sz="1300" b="1">
+                <a:solidFill>
+                  <a:srgbClr val="CC0E1E"/>
+                </a:solidFill>
+                <a:latin typeface="Calibri"/>
+              </a:rPr>
+              <a:t>—  </a:t>
+            </a:r>
+            <a:r>
+              <a:rPr sz="1300">
+                <a:solidFill>
+                  <a:srgbClr val="1A1A1A"/>
+                </a:solidFill>
+                <a:latin typeface="Calibri"/>
+              </a:rPr>
+              <a:t>8982324811 (HYDRAULIC UNIT; ANTI LOCK BRK): EUR 858 to EUR 0, 1 fewer pieces.</a:t>
             </a:r>
           </a:p>
         </p:txBody>
@@ -19883,7 +19967,7 @@
               </a:spcAft>
             </a:pPr>
             <a:r>
-              <a:rPr sz="1400" b="1">
+              <a:rPr sz="1300" b="1">
                 <a:solidFill>
                   <a:srgbClr val="CC0E1E"/>
                 </a:solidFill>
@@ -19892,13 +19976,153 @@
               <a:t>—  </a:t>
             </a:r>
             <a:r>
-              <a:rPr sz="1400">
+              <a:rPr sz="1300">
                 <a:solidFill>
                   <a:srgbClr val="1A1A1A"/>
                 </a:solidFill>
                 <a:latin typeface="Calibri"/>
               </a:rPr>
               <a:t>EUR 10,591 (CY H1 2025) to EUR 5,795 (CY H1 2026), down EUR 4,796 (-45%).</a:t>
+            </a:r>
+          </a:p>
+          <a:p>
+            <a:pPr>
+              <a:lnSpc>
+                <a:spcPct val="125000"/>
+              </a:lnSpc>
+              <a:spcAft>
+                <a:spcPts val="1000"/>
+              </a:spcAft>
+            </a:pPr>
+            <a:r>
+              <a:rPr sz="1300" b="1">
+                <a:solidFill>
+                  <a:srgbClr val="CC0E1E"/>
+                </a:solidFill>
+                <a:latin typeface="Calibri"/>
+              </a:rPr>
+              <a:t>—  </a:t>
+            </a:r>
+            <a:r>
+              <a:rPr sz="1300">
+                <a:solidFill>
+                  <a:srgbClr val="1A1A1A"/>
+                </a:solidFill>
+                <a:latin typeface="Calibri"/>
+              </a:rPr>
+              <a:t>Largest part numbers driving the decline (by EUR):</a:t>
+            </a:r>
+          </a:p>
+          <a:p>
+            <a:pPr>
+              <a:lnSpc>
+                <a:spcPct val="125000"/>
+              </a:lnSpc>
+              <a:spcAft>
+                <a:spcPts val="1000"/>
+              </a:spcAft>
+            </a:pPr>
+            <a:r>
+              <a:rPr sz="1300" b="1">
+                <a:solidFill>
+                  <a:srgbClr val="CC0E1E"/>
+                </a:solidFill>
+                <a:latin typeface="Calibri"/>
+              </a:rPr>
+              <a:t>—  </a:t>
+            </a:r>
+            <a:r>
+              <a:rPr sz="1300">
+                <a:solidFill>
+                  <a:srgbClr val="1A1A1A"/>
+                </a:solidFill>
+                <a:latin typeface="Calibri"/>
+              </a:rPr>
+              <a:t>8984890190 (NOZZLE ASM; INJ): EUR 3,865 to EUR 1,887, 12 fewer pieces.</a:t>
+            </a:r>
+          </a:p>
+          <a:p>
+            <a:pPr>
+              <a:lnSpc>
+                <a:spcPct val="125000"/>
+              </a:lnSpc>
+              <a:spcAft>
+                <a:spcPts val="1000"/>
+              </a:spcAft>
+            </a:pPr>
+            <a:r>
+              <a:rPr sz="1300" b="1">
+                <a:solidFill>
+                  <a:srgbClr val="CC0E1E"/>
+                </a:solidFill>
+                <a:latin typeface="Calibri"/>
+              </a:rPr>
+              <a:t>—  </a:t>
+            </a:r>
+            <a:r>
+              <a:rPr sz="1300">
+                <a:solidFill>
+                  <a:srgbClr val="1A1A1A"/>
+                </a:solidFill>
+                <a:latin typeface="Calibri"/>
+              </a:rPr>
+              <a:t>8983320591 (NOZZLE ASM; INJ): EUR 1,321 to EUR 0, 7 fewer pieces.</a:t>
+            </a:r>
+          </a:p>
+          <a:p>
+            <a:pPr>
+              <a:lnSpc>
+                <a:spcPct val="125000"/>
+              </a:lnSpc>
+              <a:spcAft>
+                <a:spcPts val="1000"/>
+              </a:spcAft>
+            </a:pPr>
+            <a:r>
+              <a:rPr sz="1300" b="1">
+                <a:solidFill>
+                  <a:srgbClr val="CC0E1E"/>
+                </a:solidFill>
+                <a:latin typeface="Calibri"/>
+              </a:rPr>
+              <a:t>—  </a:t>
+            </a:r>
+            <a:r>
+              <a:rPr sz="1300">
+                <a:solidFill>
+                  <a:srgbClr val="1A1A1A"/>
+                </a:solidFill>
+                <a:latin typeface="Calibri"/>
+              </a:rPr>
+              <a:t>8973865576 (PUMP ASM; INJ): EUR 886 to EUR 0, 1 fewer pieces.</a:t>
+            </a:r>
+          </a:p>
+          <a:p>
+            <a:pPr>
+              <a:lnSpc>
+                <a:spcPct val="125000"/>
+              </a:lnSpc>
+              <a:spcAft>
+                <a:spcPts val="1000"/>
+              </a:spcAft>
+            </a:pPr>
+            <a:r>
+              <a:rPr sz="1300" b="1">
+                <a:solidFill>
+                  <a:srgbClr val="CC0E1E"/>
+                </a:solidFill>
+                <a:latin typeface="Calibri"/>
+              </a:rPr>
+              <a:t>—  </a:t>
+            </a:r>
+            <a:r>
+              <a:rPr sz="1300">
+                <a:solidFill>
+                  <a:srgbClr val="1A1A1A"/>
+                </a:solidFill>
+                <a:latin typeface="Calibri"/>
+              </a:rPr>
+              <a:t>8982601090 (NOZZLE ASM; INJ): EUR 2,710 to EUR 1,909, 6 fewer pieces.</a:t>
             </a:r>
           </a:p>
         </p:txBody>
@@ -20317,7 +20541,7 @@
               </a:spcAft>
             </a:pPr>
             <a:r>
-              <a:rPr sz="1400" b="1">
+              <a:rPr sz="1300" b="1">
                 <a:solidFill>
                   <a:srgbClr val="CC0E1E"/>
                 </a:solidFill>
@@ -20326,13 +20550,153 @@
               <a:t>—  </a:t>
             </a:r>
             <a:r>
-              <a:rPr sz="1400">
+              <a:rPr sz="1300">
                 <a:solidFill>
                   <a:srgbClr val="1A1A1A"/>
                 </a:solidFill>
                 <a:latin typeface="Calibri"/>
               </a:rPr>
               <a:t>EUR 9,894 (CY H1 2025) to EUR 5,548 (CY H1 2026), down EUR 4,346 (-44%).</a:t>
+            </a:r>
+          </a:p>
+          <a:p>
+            <a:pPr>
+              <a:lnSpc>
+                <a:spcPct val="125000"/>
+              </a:lnSpc>
+              <a:spcAft>
+                <a:spcPts val="1000"/>
+              </a:spcAft>
+            </a:pPr>
+            <a:r>
+              <a:rPr sz="1300" b="1">
+                <a:solidFill>
+                  <a:srgbClr val="CC0E1E"/>
+                </a:solidFill>
+                <a:latin typeface="Calibri"/>
+              </a:rPr>
+              <a:t>—  </a:t>
+            </a:r>
+            <a:r>
+              <a:rPr sz="1300">
+                <a:solidFill>
+                  <a:srgbClr val="1A1A1A"/>
+                </a:solidFill>
+                <a:latin typeface="Calibri"/>
+              </a:rPr>
+              <a:t>Largest part numbers driving the decline (by EUR):</a:t>
+            </a:r>
+          </a:p>
+          <a:p>
+            <a:pPr>
+              <a:lnSpc>
+                <a:spcPct val="125000"/>
+              </a:lnSpc>
+              <a:spcAft>
+                <a:spcPts val="1000"/>
+              </a:spcAft>
+            </a:pPr>
+            <a:r>
+              <a:rPr sz="1300" b="1">
+                <a:solidFill>
+                  <a:srgbClr val="CC0E1E"/>
+                </a:solidFill>
+                <a:latin typeface="Calibri"/>
+              </a:rPr>
+              <a:t>—  </a:t>
+            </a:r>
+            <a:r>
+              <a:rPr sz="1300">
+                <a:solidFill>
+                  <a:srgbClr val="1A1A1A"/>
+                </a:solidFill>
+                <a:latin typeface="Calibri"/>
+              </a:rPr>
+              <a:t>8941449334 (SEDIMENTER; FUEL): EUR 2,530 to EUR 0, 51 fewer pieces.</a:t>
+            </a:r>
+          </a:p>
+          <a:p>
+            <a:pPr>
+              <a:lnSpc>
+                <a:spcPct val="125000"/>
+              </a:lnSpc>
+              <a:spcAft>
+                <a:spcPts val="1000"/>
+              </a:spcAft>
+            </a:pPr>
+            <a:r>
+              <a:rPr sz="1300" b="1">
+                <a:solidFill>
+                  <a:srgbClr val="CC0E1E"/>
+                </a:solidFill>
+                <a:latin typeface="Calibri"/>
+              </a:rPr>
+              <a:t>—  </a:t>
+            </a:r>
+            <a:r>
+              <a:rPr sz="1300">
+                <a:solidFill>
+                  <a:srgbClr val="1A1A1A"/>
+                </a:solidFill>
+                <a:latin typeface="Calibri"/>
+              </a:rPr>
+              <a:t>8981530463 (TANK; FUEL): EUR 1,645 to EUR 0, 8 fewer pieces.</a:t>
+            </a:r>
+          </a:p>
+          <a:p>
+            <a:pPr>
+              <a:lnSpc>
+                <a:spcPct val="125000"/>
+              </a:lnSpc>
+              <a:spcAft>
+                <a:spcPts val="1000"/>
+              </a:spcAft>
+            </a:pPr>
+            <a:r>
+              <a:rPr sz="1300" b="1">
+                <a:solidFill>
+                  <a:srgbClr val="CC0E1E"/>
+                </a:solidFill>
+                <a:latin typeface="Calibri"/>
+              </a:rPr>
+              <a:t>—  </a:t>
+            </a:r>
+            <a:r>
+              <a:rPr sz="1300">
+                <a:solidFill>
+                  <a:srgbClr val="1A1A1A"/>
+                </a:solidFill>
+                <a:latin typeface="Calibri"/>
+              </a:rPr>
+              <a:t>8984890171 (PUMP ASM; FUEL,SUPPLY): EUR 3,409 to EUR 2,032, 2 fewer pieces.</a:t>
+            </a:r>
+          </a:p>
+          <a:p>
+            <a:pPr>
+              <a:lnSpc>
+                <a:spcPct val="125000"/>
+              </a:lnSpc>
+              <a:spcAft>
+                <a:spcPts val="1000"/>
+              </a:spcAft>
+            </a:pPr>
+            <a:r>
+              <a:rPr sz="1300" b="1">
+                <a:solidFill>
+                  <a:srgbClr val="CC0E1E"/>
+                </a:solidFill>
+                <a:latin typeface="Calibri"/>
+              </a:rPr>
+              <a:t>—  </a:t>
+            </a:r>
+            <a:r>
+              <a:rPr sz="1300">
+                <a:solidFill>
+                  <a:srgbClr val="1A1A1A"/>
+                </a:solidFill>
+                <a:latin typeface="Calibri"/>
+              </a:rPr>
+              <a:t>8972745350 (TANK; FUEL): EUR 1,212 to EUR 0, 7 fewer pieces.</a:t>
             </a:r>
           </a:p>
         </p:txBody>
@@ -20739,10 +21103,12 @@
                 <a:tableStyleId>{5C22544A-7EE6-4342-B048-85BDC9FD1C3A}</a:tableStyleId>
               </a:tblPr>
               <a:tblGrid>
-                <a:gridCol w="2194560"/>
-                <a:gridCol w="4480560"/>
-                <a:gridCol w="2468880"/>
-                <a:gridCol w="2468880"/>
+                <a:gridCol w="1737360"/>
+                <a:gridCol w="2926080"/>
+                <a:gridCol w="1645920"/>
+                <a:gridCol w="1737360"/>
+                <a:gridCol w="1737360"/>
+                <a:gridCol w="1828800"/>
               </a:tblGrid>
               <a:tr h="339634">
                 <a:tc>
@@ -20752,7 +21118,7 @@
                     <a:p>
                       <a:pPr algn="l"/>
                       <a:r>
-                        <a:rPr sz="1200" b="1">
+                        <a:rPr sz="1100" b="1">
                           <a:solidFill>
                             <a:srgbClr val="FFFFFF"/>
                           </a:solidFill>
@@ -20775,7 +21141,7 @@
                     <a:p>
                       <a:pPr algn="l"/>
                       <a:r>
-                        <a:rPr sz="1200" b="1">
+                        <a:rPr sz="1100" b="1">
                           <a:solidFill>
                             <a:srgbClr val="FFFFFF"/>
                           </a:solidFill>
@@ -20796,9 +21162,32 @@
                     <a:bodyPr/>
                     <a:lstStyle/>
                     <a:p>
+                      <a:pPr algn="l"/>
+                      <a:r>
+                        <a:rPr sz="1100" b="1">
+                          <a:solidFill>
+                            <a:srgbClr val="FFFFFF"/>
+                          </a:solidFill>
+                          <a:latin typeface="Calibri"/>
+                        </a:rPr>
+                        <a:t>Model</a:t>
+                      </a:r>
+                    </a:p>
+                  </a:txBody>
+                  <a:tcPr anchor="ctr" marL="73152" marR="73152">
+                    <a:solidFill>
+                      <a:srgbClr val="CC0E1E"/>
+                    </a:solidFill>
+                  </a:tcPr>
+                </a:tc>
+                <a:tc>
+                  <a:txBody>
+                    <a:bodyPr/>
+                    <a:lstStyle/>
+                    <a:p>
                       <a:pPr algn="r"/>
                       <a:r>
-                        <a:rPr sz="1200" b="1">
+                        <a:rPr sz="1100" b="1">
                           <a:solidFill>
                             <a:srgbClr val="FFFFFF"/>
                           </a:solidFill>
@@ -20821,13 +21210,36 @@
                     <a:p>
                       <a:pPr algn="r"/>
                       <a:r>
-                        <a:rPr sz="1200" b="1">
+                        <a:rPr sz="1100" b="1">
                           <a:solidFill>
                             <a:srgbClr val="FFFFFF"/>
                           </a:solidFill>
                           <a:latin typeface="Calibri"/>
                         </a:rPr>
                         <a:t>CY H1 2026</a:t>
+                      </a:r>
+                    </a:p>
+                  </a:txBody>
+                  <a:tcPr anchor="ctr" marL="73152" marR="73152">
+                    <a:solidFill>
+                      <a:srgbClr val="CC0E1E"/>
+                    </a:solidFill>
+                  </a:tcPr>
+                </a:tc>
+                <a:tc>
+                  <a:txBody>
+                    <a:bodyPr/>
+                    <a:lstStyle/>
+                    <a:p>
+                      <a:pPr algn="r"/>
+                      <a:r>
+                        <a:rPr sz="1100" b="1">
+                          <a:solidFill>
+                            <a:srgbClr val="FFFFFF"/>
+                          </a:solidFill>
+                          <a:latin typeface="Calibri"/>
+                        </a:rPr>
+                        <a:t>Δ EUR</a:t>
                       </a:r>
                     </a:p>
                   </a:txBody>
@@ -20846,7 +21258,7 @@
                     <a:p>
                       <a:pPr algn="l"/>
                       <a:r>
-                        <a:rPr sz="1200" b="0">
+                        <a:rPr sz="1100" b="0">
                           <a:solidFill>
                             <a:srgbClr val="1A1A1A"/>
                           </a:solidFill>
@@ -20869,7 +21281,7 @@
                     <a:p>
                       <a:pPr algn="l"/>
                       <a:r>
-                        <a:rPr sz="1200" b="0">
+                        <a:rPr sz="1100" b="0">
                           <a:solidFill>
                             <a:srgbClr val="1A1A1A"/>
                           </a:solidFill>
@@ -20890,9 +21302,32 @@
                     <a:bodyPr/>
                     <a:lstStyle/>
                     <a:p>
+                      <a:pPr algn="l"/>
+                      <a:r>
+                        <a:rPr sz="1100" b="0">
+                          <a:solidFill>
+                            <a:srgbClr val="1A1A1A"/>
+                          </a:solidFill>
+                          <a:latin typeface="Calibri"/>
+                        </a:rPr>
+                        <a:t>—</a:t>
+                      </a:r>
+                    </a:p>
+                  </a:txBody>
+                  <a:tcPr anchor="ctr" marL="73152" marR="73152">
+                    <a:solidFill>
+                      <a:srgbClr val="FFFFFF"/>
+                    </a:solidFill>
+                  </a:tcPr>
+                </a:tc>
+                <a:tc>
+                  <a:txBody>
+                    <a:bodyPr/>
+                    <a:lstStyle/>
+                    <a:p>
                       <a:pPr algn="r"/>
                       <a:r>
-                        <a:rPr sz="1200" b="0">
+                        <a:rPr sz="1100" b="0">
                           <a:solidFill>
                             <a:srgbClr val="1A1A1A"/>
                           </a:solidFill>
@@ -20915,13 +21350,36 @@
                     <a:p>
                       <a:pPr algn="r"/>
                       <a:r>
-                        <a:rPr sz="1200" b="0">
+                        <a:rPr sz="1100" b="0">
                           <a:solidFill>
                             <a:srgbClr val="1A1A1A"/>
                           </a:solidFill>
                           <a:latin typeface="Calibri"/>
                         </a:rPr>
                         <a:t>EUR 18,240</a:t>
+                      </a:r>
+                    </a:p>
+                  </a:txBody>
+                  <a:tcPr anchor="ctr" marL="73152" marR="73152">
+                    <a:solidFill>
+                      <a:srgbClr val="FFFFFF"/>
+                    </a:solidFill>
+                  </a:tcPr>
+                </a:tc>
+                <a:tc>
+                  <a:txBody>
+                    <a:bodyPr/>
+                    <a:lstStyle/>
+                    <a:p>
+                      <a:pPr algn="r"/>
+                      <a:r>
+                        <a:rPr sz="1100" b="0">
+                          <a:solidFill>
+                            <a:srgbClr val="1A1A1A"/>
+                          </a:solidFill>
+                          <a:latin typeface="Calibri"/>
+                        </a:rPr>
+                        <a:t>EUR 17,542</a:t>
                       </a:r>
                     </a:p>
                   </a:txBody>
@@ -20940,7 +21398,7 @@
                     <a:p>
                       <a:pPr algn="l"/>
                       <a:r>
-                        <a:rPr sz="1200" b="0">
+                        <a:rPr sz="1100" b="0">
                           <a:solidFill>
                             <a:srgbClr val="1A1A1A"/>
                           </a:solidFill>
@@ -20963,7 +21421,7 @@
                     <a:p>
                       <a:pPr algn="l"/>
                       <a:r>
-                        <a:rPr sz="1200" b="0">
+                        <a:rPr sz="1100" b="0">
                           <a:solidFill>
                             <a:srgbClr val="1A1A1A"/>
                           </a:solidFill>
@@ -20984,9 +21442,32 @@
                     <a:bodyPr/>
                     <a:lstStyle/>
                     <a:p>
+                      <a:pPr algn="l"/>
+                      <a:r>
+                        <a:rPr sz="1100" b="0">
+                          <a:solidFill>
+                            <a:srgbClr val="1A1A1A"/>
+                          </a:solidFill>
+                          <a:latin typeface="Calibri"/>
+                        </a:rPr>
+                        <a:t>—</a:t>
+                      </a:r>
+                    </a:p>
+                  </a:txBody>
+                  <a:tcPr anchor="ctr" marL="73152" marR="73152">
+                    <a:solidFill>
+                      <a:srgbClr val="ECECEC"/>
+                    </a:solidFill>
+                  </a:tcPr>
+                </a:tc>
+                <a:tc>
+                  <a:txBody>
+                    <a:bodyPr/>
+                    <a:lstStyle/>
+                    <a:p>
                       <a:pPr algn="r"/>
                       <a:r>
-                        <a:rPr sz="1200" b="0">
+                        <a:rPr sz="1100" b="0">
                           <a:solidFill>
                             <a:srgbClr val="1A1A1A"/>
                           </a:solidFill>
@@ -21009,13 +21490,36 @@
                     <a:p>
                       <a:pPr algn="r"/>
                       <a:r>
-                        <a:rPr sz="1200" b="0">
+                        <a:rPr sz="1100" b="0">
                           <a:solidFill>
                             <a:srgbClr val="1A1A1A"/>
                           </a:solidFill>
                           <a:latin typeface="Calibri"/>
                         </a:rPr>
                         <a:t>EUR 11,992</a:t>
+                      </a:r>
+                    </a:p>
+                  </a:txBody>
+                  <a:tcPr anchor="ctr" marL="73152" marR="73152">
+                    <a:solidFill>
+                      <a:srgbClr val="ECECEC"/>
+                    </a:solidFill>
+                  </a:tcPr>
+                </a:tc>
+                <a:tc>
+                  <a:txBody>
+                    <a:bodyPr/>
+                    <a:lstStyle/>
+                    <a:p>
+                      <a:pPr algn="r"/>
+                      <a:r>
+                        <a:rPr sz="1100" b="0">
+                          <a:solidFill>
+                            <a:srgbClr val="1A1A1A"/>
+                          </a:solidFill>
+                          <a:latin typeface="Calibri"/>
+                        </a:rPr>
+                        <a:t>EUR 7,856</a:t>
                       </a:r>
                     </a:p>
                   </a:txBody>
@@ -21034,7 +21538,7 @@
                     <a:p>
                       <a:pPr algn="l"/>
                       <a:r>
-                        <a:rPr sz="1200" b="0">
+                        <a:rPr sz="1100" b="0">
                           <a:solidFill>
                             <a:srgbClr val="1A1A1A"/>
                           </a:solidFill>
@@ -21057,7 +21561,7 @@
                     <a:p>
                       <a:pPr algn="l"/>
                       <a:r>
-                        <a:rPr sz="1200" b="0">
+                        <a:rPr sz="1100" b="0">
                           <a:solidFill>
                             <a:srgbClr val="1A1A1A"/>
                           </a:solidFill>
@@ -21078,9 +21582,32 @@
                     <a:bodyPr/>
                     <a:lstStyle/>
                     <a:p>
+                      <a:pPr algn="l"/>
+                      <a:r>
+                        <a:rPr sz="1100" b="0">
+                          <a:solidFill>
+                            <a:srgbClr val="1A1A1A"/>
+                          </a:solidFill>
+                          <a:latin typeface="Calibri"/>
+                        </a:rPr>
+                        <a:t>TF*,UC*</a:t>
+                      </a:r>
+                    </a:p>
+                  </a:txBody>
+                  <a:tcPr anchor="ctr" marL="73152" marR="73152">
+                    <a:solidFill>
+                      <a:srgbClr val="FFFFFF"/>
+                    </a:solidFill>
+                  </a:tcPr>
+                </a:tc>
+                <a:tc>
+                  <a:txBody>
+                    <a:bodyPr/>
+                    <a:lstStyle/>
+                    <a:p>
                       <a:pPr algn="r"/>
                       <a:r>
-                        <a:rPr sz="1200" b="0">
+                        <a:rPr sz="1100" b="0">
                           <a:solidFill>
                             <a:srgbClr val="1A1A1A"/>
                           </a:solidFill>
@@ -21103,13 +21630,36 @@
                     <a:p>
                       <a:pPr algn="r"/>
                       <a:r>
-                        <a:rPr sz="1200" b="0">
+                        <a:rPr sz="1100" b="0">
                           <a:solidFill>
                             <a:srgbClr val="1A1A1A"/>
                           </a:solidFill>
                           <a:latin typeface="Calibri"/>
                         </a:rPr>
                         <a:t>EUR 16,468</a:t>
+                      </a:r>
+                    </a:p>
+                  </a:txBody>
+                  <a:tcPr anchor="ctr" marL="73152" marR="73152">
+                    <a:solidFill>
+                      <a:srgbClr val="FFFFFF"/>
+                    </a:solidFill>
+                  </a:tcPr>
+                </a:tc>
+                <a:tc>
+                  <a:txBody>
+                    <a:bodyPr/>
+                    <a:lstStyle/>
+                    <a:p>
+                      <a:pPr algn="r"/>
+                      <a:r>
+                        <a:rPr sz="1100" b="0">
+                          <a:solidFill>
+                            <a:srgbClr val="1A1A1A"/>
+                          </a:solidFill>
+                          <a:latin typeface="Calibri"/>
+                        </a:rPr>
+                        <a:t>EUR 6,684</a:t>
                       </a:r>
                     </a:p>
                   </a:txBody>
@@ -21128,7 +21678,7 @@
                     <a:p>
                       <a:pPr algn="l"/>
                       <a:r>
-                        <a:rPr sz="1200" b="0">
+                        <a:rPr sz="1100" b="0">
                           <a:solidFill>
                             <a:srgbClr val="1A1A1A"/>
                           </a:solidFill>
@@ -21151,7 +21701,7 @@
                     <a:p>
                       <a:pPr algn="l"/>
                       <a:r>
-                        <a:rPr sz="1200" b="0">
+                        <a:rPr sz="1100" b="0">
                           <a:solidFill>
                             <a:srgbClr val="1A1A1A"/>
                           </a:solidFill>
@@ -21172,9 +21722,32 @@
                     <a:bodyPr/>
                     <a:lstStyle/>
                     <a:p>
+                      <a:pPr algn="l"/>
+                      <a:r>
+                        <a:rPr sz="1100" b="0">
+                          <a:solidFill>
+                            <a:srgbClr val="1A1A1A"/>
+                          </a:solidFill>
+                          <a:latin typeface="Calibri"/>
+                        </a:rPr>
+                        <a:t>—</a:t>
+                      </a:r>
+                    </a:p>
+                  </a:txBody>
+                  <a:tcPr anchor="ctr" marL="73152" marR="73152">
+                    <a:solidFill>
+                      <a:srgbClr val="ECECEC"/>
+                    </a:solidFill>
+                  </a:tcPr>
+                </a:tc>
+                <a:tc>
+                  <a:txBody>
+                    <a:bodyPr/>
+                    <a:lstStyle/>
+                    <a:p>
                       <a:pPr algn="r"/>
                       <a:r>
-                        <a:rPr sz="1200" b="0">
+                        <a:rPr sz="1100" b="0">
                           <a:solidFill>
                             <a:srgbClr val="1A1A1A"/>
                           </a:solidFill>
@@ -21197,13 +21770,36 @@
                     <a:p>
                       <a:pPr algn="r"/>
                       <a:r>
-                        <a:rPr sz="1200" b="0">
+                        <a:rPr sz="1100" b="0">
                           <a:solidFill>
                             <a:srgbClr val="1A1A1A"/>
                           </a:solidFill>
                           <a:latin typeface="Calibri"/>
                         </a:rPr>
                         <a:t>EUR 8,352</a:t>
+                      </a:r>
+                    </a:p>
+                  </a:txBody>
+                  <a:tcPr anchor="ctr" marL="73152" marR="73152">
+                    <a:solidFill>
+                      <a:srgbClr val="ECECEC"/>
+                    </a:solidFill>
+                  </a:tcPr>
+                </a:tc>
+                <a:tc>
+                  <a:txBody>
+                    <a:bodyPr/>
+                    <a:lstStyle/>
+                    <a:p>
+                      <a:pPr algn="r"/>
+                      <a:r>
+                        <a:rPr sz="1100" b="0">
+                          <a:solidFill>
+                            <a:srgbClr val="1A1A1A"/>
+                          </a:solidFill>
+                          <a:latin typeface="Calibri"/>
+                        </a:rPr>
+                        <a:t>EUR 6,229</a:t>
                       </a:r>
                     </a:p>
                   </a:txBody>
@@ -21222,7 +21818,7 @@
                     <a:p>
                       <a:pPr algn="l"/>
                       <a:r>
-                        <a:rPr sz="1200" b="0">
+                        <a:rPr sz="1100" b="0">
                           <a:solidFill>
                             <a:srgbClr val="1A1A1A"/>
                           </a:solidFill>
@@ -21245,7 +21841,7 @@
                     <a:p>
                       <a:pPr algn="l"/>
                       <a:r>
-                        <a:rPr sz="1200" b="0">
+                        <a:rPr sz="1100" b="0">
                           <a:solidFill>
                             <a:srgbClr val="1A1A1A"/>
                           </a:solidFill>
@@ -21266,9 +21862,32 @@
                     <a:bodyPr/>
                     <a:lstStyle/>
                     <a:p>
+                      <a:pPr algn="l"/>
+                      <a:r>
+                        <a:rPr sz="1100" b="0">
+                          <a:solidFill>
+                            <a:srgbClr val="1A1A1A"/>
+                          </a:solidFill>
+                          <a:latin typeface="Calibri"/>
+                        </a:rPr>
+                        <a:t>—</a:t>
+                      </a:r>
+                    </a:p>
+                  </a:txBody>
+                  <a:tcPr anchor="ctr" marL="73152" marR="73152">
+                    <a:solidFill>
+                      <a:srgbClr val="FFFFFF"/>
+                    </a:solidFill>
+                  </a:tcPr>
+                </a:tc>
+                <a:tc>
+                  <a:txBody>
+                    <a:bodyPr/>
+                    <a:lstStyle/>
+                    <a:p>
                       <a:pPr algn="r"/>
                       <a:r>
-                        <a:rPr sz="1200" b="0">
+                        <a:rPr sz="1100" b="0">
                           <a:solidFill>
                             <a:srgbClr val="1A1A1A"/>
                           </a:solidFill>
@@ -21291,13 +21910,36 @@
                     <a:p>
                       <a:pPr algn="r"/>
                       <a:r>
-                        <a:rPr sz="1200" b="0">
+                        <a:rPr sz="1100" b="0">
                           <a:solidFill>
                             <a:srgbClr val="1A1A1A"/>
                           </a:solidFill>
                           <a:latin typeface="Calibri"/>
                         </a:rPr>
                         <a:t>EUR 6,849</a:t>
+                      </a:r>
+                    </a:p>
+                  </a:txBody>
+                  <a:tcPr anchor="ctr" marL="73152" marR="73152">
+                    <a:solidFill>
+                      <a:srgbClr val="FFFFFF"/>
+                    </a:solidFill>
+                  </a:tcPr>
+                </a:tc>
+                <a:tc>
+                  <a:txBody>
+                    <a:bodyPr/>
+                    <a:lstStyle/>
+                    <a:p>
+                      <a:pPr algn="r"/>
+                      <a:r>
+                        <a:rPr sz="1100" b="0">
+                          <a:solidFill>
+                            <a:srgbClr val="1A1A1A"/>
+                          </a:solidFill>
+                          <a:latin typeface="Calibri"/>
+                        </a:rPr>
+                        <a:t>EUR 4,566</a:t>
                       </a:r>
                     </a:p>
                   </a:txBody>
@@ -21316,7 +21958,7 @@
                     <a:p>
                       <a:pPr algn="l"/>
                       <a:r>
-                        <a:rPr sz="1200" b="0">
+                        <a:rPr sz="1100" b="0">
                           <a:solidFill>
                             <a:srgbClr val="1A1A1A"/>
                           </a:solidFill>
@@ -21339,7 +21981,7 @@
                     <a:p>
                       <a:pPr algn="l"/>
                       <a:r>
-                        <a:rPr sz="1200" b="0">
+                        <a:rPr sz="1100" b="0">
                           <a:solidFill>
                             <a:srgbClr val="1A1A1A"/>
                           </a:solidFill>
@@ -21360,9 +22002,32 @@
                     <a:bodyPr/>
                     <a:lstStyle/>
                     <a:p>
+                      <a:pPr algn="l"/>
+                      <a:r>
+                        <a:rPr sz="1100" b="0">
+                          <a:solidFill>
+                            <a:srgbClr val="1A1A1A"/>
+                          </a:solidFill>
+                          <a:latin typeface="Calibri"/>
+                        </a:rPr>
+                        <a:t>—</a:t>
+                      </a:r>
+                    </a:p>
+                  </a:txBody>
+                  <a:tcPr anchor="ctr" marL="73152" marR="73152">
+                    <a:solidFill>
+                      <a:srgbClr val="ECECEC"/>
+                    </a:solidFill>
+                  </a:tcPr>
+                </a:tc>
+                <a:tc>
+                  <a:txBody>
+                    <a:bodyPr/>
+                    <a:lstStyle/>
+                    <a:p>
                       <a:pPr algn="r"/>
                       <a:r>
-                        <a:rPr sz="1200" b="0">
+                        <a:rPr sz="1100" b="0">
                           <a:solidFill>
                             <a:srgbClr val="1A1A1A"/>
                           </a:solidFill>
@@ -21385,7 +22050,7 @@
                     <a:p>
                       <a:pPr algn="r"/>
                       <a:r>
-                        <a:rPr sz="1200" b="0">
+                        <a:rPr sz="1100" b="0">
                           <a:solidFill>
                             <a:srgbClr val="1A1A1A"/>
                           </a:solidFill>
@@ -21401,6 +22066,29 @@
                     </a:solidFill>
                   </a:tcPr>
                 </a:tc>
+                <a:tc>
+                  <a:txBody>
+                    <a:bodyPr/>
+                    <a:lstStyle/>
+                    <a:p>
+                      <a:pPr algn="r"/>
+                      <a:r>
+                        <a:rPr sz="1100" b="0">
+                          <a:solidFill>
+                            <a:srgbClr val="1A1A1A"/>
+                          </a:solidFill>
+                          <a:latin typeface="Calibri"/>
+                        </a:rPr>
+                        <a:t>EUR 4,524</a:t>
+                      </a:r>
+                    </a:p>
+                  </a:txBody>
+                  <a:tcPr anchor="ctr" marL="73152" marR="73152">
+                    <a:solidFill>
+                      <a:srgbClr val="ECECEC"/>
+                    </a:solidFill>
+                  </a:tcPr>
+                </a:tc>
               </a:tr>
             </a:tbl>
           </a:graphicData>
@@ -21508,7 +22196,7 @@
                 </a:solidFill>
                 <a:latin typeface="Calibri"/>
               </a:rPr>
-              <a:t>Worth agreeing which of these are repeatable and which were one-off.</a:t>
+              <a:t>PNs ranked by largest EUR increase (prior-period sales &gt; 0). Worth agreeing which of these are repeatable and which were one-off.</a:t>
             </a:r>
           </a:p>
         </p:txBody>

</xml_diff>